<commit_message>
update code based on Mac on 20261027
</commit_message>
<xml_diff>
--- a/xiaozhan_Nightly/User Guide.pptx
+++ b/xiaozhan_Nightly/User Guide.pptx
@@ -2655,7 +2655,7 @@
         <a:spcBef>
           <a:spcPts val="1000"/>
         </a:spcBef>
-        <a:buFont typeface="Arial" panose="020B0604020202020204" pitchFamily="34" charset="0"/>
+        <a:buFont typeface="Arial" panose="020B0604020202090204" pitchFamily="34" charset="0"/>
         <a:buChar char="•"/>
         <a:defRPr sz="2800" kern="1200">
           <a:solidFill>
@@ -2673,7 +2673,7 @@
         <a:spcBef>
           <a:spcPts val="500"/>
         </a:spcBef>
-        <a:buFont typeface="Arial" panose="020B0604020202020204" pitchFamily="34" charset="0"/>
+        <a:buFont typeface="Arial" panose="020B0604020202090204" pitchFamily="34" charset="0"/>
         <a:buChar char="•"/>
         <a:defRPr sz="2400" kern="1200">
           <a:solidFill>
@@ -2691,7 +2691,7 @@
         <a:spcBef>
           <a:spcPts val="500"/>
         </a:spcBef>
-        <a:buFont typeface="Arial" panose="020B0604020202020204" pitchFamily="34" charset="0"/>
+        <a:buFont typeface="Arial" panose="020B0604020202090204" pitchFamily="34" charset="0"/>
         <a:buChar char="•"/>
         <a:defRPr sz="2000" kern="1200">
           <a:solidFill>
@@ -2709,7 +2709,7 @@
         <a:spcBef>
           <a:spcPts val="500"/>
         </a:spcBef>
-        <a:buFont typeface="Arial" panose="020B0604020202020204" pitchFamily="34" charset="0"/>
+        <a:buFont typeface="Arial" panose="020B0604020202090204" pitchFamily="34" charset="0"/>
         <a:buChar char="•"/>
         <a:defRPr sz="1800" kern="1200">
           <a:solidFill>
@@ -2727,7 +2727,7 @@
         <a:spcBef>
           <a:spcPts val="500"/>
         </a:spcBef>
-        <a:buFont typeface="Arial" panose="020B0604020202020204" pitchFamily="34" charset="0"/>
+        <a:buFont typeface="Arial" panose="020B0604020202090204" pitchFamily="34" charset="0"/>
         <a:buChar char="•"/>
         <a:defRPr sz="1800" kern="1200">
           <a:solidFill>
@@ -2745,7 +2745,7 @@
         <a:spcBef>
           <a:spcPts val="500"/>
         </a:spcBef>
-        <a:buFont typeface="Arial" panose="020B0604020202020204" pitchFamily="34" charset="0"/>
+        <a:buFont typeface="Arial" panose="020B0604020202090204" pitchFamily="34" charset="0"/>
         <a:buChar char="•"/>
         <a:defRPr sz="1800" kern="1200">
           <a:solidFill>
@@ -2763,7 +2763,7 @@
         <a:spcBef>
           <a:spcPts val="500"/>
         </a:spcBef>
-        <a:buFont typeface="Arial" panose="020B0604020202020204" pitchFamily="34" charset="0"/>
+        <a:buFont typeface="Arial" panose="020B0604020202090204" pitchFamily="34" charset="0"/>
         <a:buChar char="•"/>
         <a:defRPr sz="1800" kern="1200">
           <a:solidFill>
@@ -2781,7 +2781,7 @@
         <a:spcBef>
           <a:spcPts val="500"/>
         </a:spcBef>
-        <a:buFont typeface="Arial" panose="020B0604020202020204" pitchFamily="34" charset="0"/>
+        <a:buFont typeface="Arial" panose="020B0604020202090204" pitchFamily="34" charset="0"/>
         <a:buChar char="•"/>
         <a:defRPr sz="1800" kern="1200">
           <a:solidFill>
@@ -2799,7 +2799,7 @@
         <a:spcBef>
           <a:spcPts val="500"/>
         </a:spcBef>
-        <a:buFont typeface="Arial" panose="020B0604020202020204" pitchFamily="34" charset="0"/>
+        <a:buFont typeface="Arial" panose="020B0604020202090204" pitchFamily="34" charset="0"/>
         <a:buChar char="•"/>
         <a:defRPr sz="1800" kern="1200">
           <a:solidFill>
@@ -2936,7 +2936,7 @@
           <a:p>
             <a:r>
               <a:rPr lang="en-US" altLang="zh-CN"/>
-              <a:t>User Guide Only For Wind River</a:t>
+              <a:t>Automation User Guide Only For Wind River</a:t>
             </a:r>
             <a:endParaRPr lang="en-US" altLang="zh-CN"/>
           </a:p>
@@ -3005,7 +3005,7 @@
           <a:p>
             <a:r>
               <a:rPr lang="en-US" altLang="zh-CN"/>
-              <a:t>                          Entry Point</a:t>
+              <a:t>                      Entry Point</a:t>
             </a:r>
             <a:endParaRPr lang="en-US" altLang="zh-CN"/>
           </a:p>

</xml_diff>